<commit_message>
Add standalone script to check outlet coordinates in the sea
This script counts the number of outlet coordinates that fall in the sea,
verifying the output of the Silver layer's bounding box check. It enriches
the findings with master attributes and outputs the results to a CSV file
and a markdown file for forensics. The script does not modify any predictions
or pipeline processes, serving purely as an observational tool.
</commit_message>
<xml_diff>
--- a/report/DataX_round2_pitch_deck.pptx
+++ b/report/DataX_round2_pitch_deck.pptx
@@ -587,7 +587,7 @@
               <a:rPr sz="1100">
                 <a:latin typeface="Calibri"/>
               </a:rPr>
-              <a:t>Five numbers to take away. Twenty-eight-point-six million rupees of net value from the cooler programme. Two hundred outlets we can save before they go dormant. The first per-outlet trade-spend split this organisation has ever had. A two-standard-deviation gap between our best and worst distributor — already actionable. And every recommendation in the system is traceable, both to its data driver and to its alternative scenario. Questions.
+              <a:t>Five numbers to take away. Thirty-one-point-six-five million rupees of net value from the cooler programme. Two hundred outlets we can save before they go dormant. The first per-outlet trade-spend split this organisation has ever had. A two-standard-deviation gap between our best and worst distributor — already actionable. And every recommendation in the system is traceable, both to its data driver and to its alternative scenario. Questions.
 --- BACKUP TALKING POINTS FOR Q&amp;A ---
 [LIMITATIONS] β (litres-per-LKR elasticity) is uncalibrated — published as a sensitivity sweep, not a point estimate. Counterfactuals are model-predicted, not empirically validated (dataset has no cooler-install dates). Channel-split weights come from marketing-mix-modelling literature, not from data — the pilot programme calibrates these. OSM POI coverage is patchier in rural districts; within-province tier normalisation mitigates but does not eliminate the bias.
 [WHY NO ML] A supervised learner trained on V reproduces V in expectation — including its censoring. Tobit (Tobin 1958) and SFA (Aigner et al 1977) explicitly model D ≥ V when the constraint binds — which is the problem. Five independent textbook estimators converging on the same ranking is stronger evidence than one tuned ML model.
@@ -1030,7 +1030,7 @@
               <a:rPr sz="1100">
                 <a:latin typeface="Calibri"/>
               </a:rPr>
-              <a:t>If leadership took one decision from this submission, it should be this one. Of the seven thousand outlets without a cooler today, our model identifies one hundred that pay back the cooler in under four months on average and generate twenty-eight-point-six million rupees of net margin in two years — almost six times the capital deployed. The full ranked list is inside the web app.</a:t>
+              <a:t>If leadership took one decision from this submission, it should be this one. Of the outlets without a cooler today, our model identifies one hundred that pay back the cooler in under three-and-a-half months on average and generate thirty-one-point-six-five million rupees of net margin in two years — more than six times the capital deployed. The full ranked list is inside the web app.</a:t>
             </a:r>
           </a:p>
         </p:txBody>
@@ -1103,7 +1103,7 @@
               <a:rPr sz="1100">
                 <a:latin typeface="Calibri"/>
               </a:rPr>
-              <a:t>[Switch to live web app at localhost:3000.] Dashboard — total predicted potential six-point-three-five million litres, LKR 5 M allocated. [Click Outlets, filter Western + Grocery + Medium.] Twelve hundred outlets. [Click any high-potential outlet.] Drill-down. Top reasons. Click 'Explain this outlet.' Gemini returns two paragraphs and three actions. [Switch to Insights.] Cooler ROI, dormancy, scorecard, territories on a map. Five minutes total.</a:t>
+              <a:t>[Switch to live web app at localhost:3000.] Dashboard — total predicted potential six-point-six million litres, LKR 5 M allocated. [Click Outlets, filter Western + Grocery + Medium.] Twelve hundred outlets. [Click any high-potential outlet.] Drill-down. Top reasons. Click 'Explain this outlet.' Gemini returns two paragraphs and three actions. [Switch to Insights.] Cooler ROI, dormancy, scorecard, territories on a map. Five minutes total.</a:t>
             </a:r>
           </a:p>
         </p:txBody>
@@ -4610,7 +4610,7 @@
                 </a:solidFill>
                 <a:latin typeface="Calibri"/>
               </a:rPr>
-              <a:t>0.794</a:t>
+              <a:t>0.793</a:t>
             </a:r>
           </a:p>
         </p:txBody>
@@ -4727,7 +4727,7 @@
                 </a:solidFill>
                 <a:latin typeface="Calibri"/>
               </a:rPr>
-              <a:t>4,999,956</a:t>
+              <a:t>4,999,913</a:t>
             </a:r>
           </a:p>
         </p:txBody>
@@ -4844,7 +4844,7 @@
                 </a:solidFill>
                 <a:latin typeface="Calibri"/>
               </a:rPr>
-              <a:t>LKR 28.6 M</a:t>
+              <a:t>LKR 31.65 M</a:t>
             </a:r>
           </a:p>
         </p:txBody>
@@ -5252,7 +5252,7 @@
                 </a:solidFill>
                 <a:latin typeface="Calibri"/>
               </a:rPr>
-              <a:t>LKR 28.6 M net 24-month value from a LKR 5 M cooler programme</a:t>
+              <a:t>LKR 31.65 M net 24-month value from a LKR 5 M cooler programme</a:t>
             </a:r>
           </a:p>
         </p:txBody>
@@ -5564,7 +5564,7 @@
                 </a:solidFill>
                 <a:latin typeface="Calibri"/>
               </a:rPr>
-              <a:t>First per-outlet split of trade spend (35 / 42 / 23)</a:t>
+              <a:t>First per-outlet split of trade spend (34.9 / 41.8 / 23.3)</a:t>
             </a:r>
           </a:p>
         </p:txBody>
@@ -10129,7 +10129,7 @@
                 </a:solidFill>
                 <a:latin typeface="Calibri"/>
               </a:rPr>
-              <a:t>0.794</a:t>
+              <a:t>0.793</a:t>
             </a:r>
           </a:p>
         </p:txBody>
@@ -10164,7 +10164,7 @@
                 </a:solidFill>
                 <a:latin typeface="Calibri"/>
               </a:rPr>
-              <a:t>over 11,256 evaluable outlets</a:t>
+              <a:t>over 10,949 evaluable outlets</a:t>
             </a:r>
           </a:p>
         </p:txBody>
@@ -11374,7 +11374,7 @@
                 </a:solidFill>
                 <a:latin typeface="Calibri"/>
               </a:rPr>
-              <a:t>share of LKR 5 M  ·  35 %</a:t>
+              <a:t>share of LKR 5 M  ·  34.9 %</a:t>
             </a:r>
           </a:p>
         </p:txBody>
@@ -11573,7 +11573,7 @@
                 </a:solidFill>
                 <a:latin typeface="Calibri"/>
               </a:rPr>
-              <a:t>LKR 2.10 M</a:t>
+              <a:t>LKR 2.09 M</a:t>
             </a:r>
           </a:p>
         </p:txBody>
@@ -11608,7 +11608,7 @@
                 </a:solidFill>
                 <a:latin typeface="Calibri"/>
               </a:rPr>
-              <a:t>share of LKR 5 M  ·  42 %</a:t>
+              <a:t>share of LKR 5 M  ·  41.8 %</a:t>
             </a:r>
           </a:p>
         </p:txBody>
@@ -11807,7 +11807,7 @@
                 </a:solidFill>
                 <a:latin typeface="Calibri"/>
               </a:rPr>
-              <a:t>LKR 1.16 M</a:t>
+              <a:t>LKR 1.17 M</a:t>
             </a:r>
           </a:p>
         </p:txBody>
@@ -11842,7 +11842,7 @@
                 </a:solidFill>
                 <a:latin typeface="Calibri"/>
               </a:rPr>
-              <a:t>share of LKR 5 M  ·  23 %</a:t>
+              <a:t>share of LKR 5 M  ·  23.3 %</a:t>
             </a:r>
           </a:p>
         </p:txBody>
@@ -11920,7 +11920,7 @@
                 </a:solidFill>
                 <a:latin typeface="Calibri"/>
               </a:rPr>
-              <a:t>LKR 4,999,955.90 allocated across 8,803 funded outlets (186 zero-uplift outlets correctly excluded).</a:t>
+              <a:t>LKR 4,999,912.87 allocated across 8,416 funded outlets (172 zero-uplift outlets correctly excluded).</a:t>
             </a:r>
           </a:p>
         </p:txBody>
@@ -12242,7 +12242,7 @@
                 </a:solidFill>
                 <a:latin typeface="Calibri"/>
               </a:rPr>
-              <a:t>LKR 28.6 M</a:t>
+              <a:t>LKR 31.65 M</a:t>
             </a:r>
           </a:p>
         </p:txBody>
@@ -12277,7 +12277,7 @@
                 </a:solidFill>
                 <a:latin typeface="Calibri"/>
               </a:rPr>
-              <a:t>from a LKR 5 M cooler programme  ·  median payback 3.6 months</a:t>
+              <a:t>from a LKR 5 M cooler programme  ·  median payback 3.33 months</a:t>
             </a:r>
           </a:p>
         </p:txBody>
@@ -12437,7 +12437,7 @@
                           </a:solidFill>
                           <a:latin typeface="Calibri"/>
                         </a:rPr>
-                        <a:t>LKR 33,629,125</a:t>
+                        <a:t>LKR 36,650,325</a:t>
                       </a:r>
                     </a:p>
                   </a:txBody>
@@ -12485,7 +12485,7 @@
                           </a:solidFill>
                           <a:latin typeface="Calibri"/>
                         </a:rPr>
-                        <a:t>LKR 28,629,125</a:t>
+                        <a:t>LKR 31,650,325</a:t>
                       </a:r>
                     </a:p>
                   </a:txBody>
@@ -12533,7 +12533,7 @@
                           </a:solidFill>
                           <a:latin typeface="Calibri"/>
                         </a:rPr>
-                        <a:t>3.6 months</a:t>
+                        <a:t>3.33 months</a:t>
                       </a:r>
                     </a:p>
                   </a:txBody>
@@ -12581,7 +12581,7 @@
                           </a:solidFill>
                           <a:latin typeface="Calibri"/>
                         </a:rPr>
-                        <a:t>7,028</a:t>
+                        <a:t>~6,500</a:t>
                       </a:r>
                     </a:p>
                   </a:txBody>

</xml_diff>